<commit_message>
Add GitHub repository QR code to poster
</commit_message>
<xml_diff>
--- a/docs/poster/MedLocate-poster.pptx
+++ b/docs/poster/MedLocate-poster.pptx
@@ -8180,7 +8180,7 @@
             <p:nvPr/>
           </p:nvPicPr>
           <p:blipFill>
-            <a:blip r:embed="rId7"/>
+            <a:blip r:embed="rId13"/>
             <a:stretch>
               <a:fillRect/>
             </a:stretch>
@@ -8220,6 +8220,41 @@
           </p:spPr>
         </p:pic>
       </p:grpSp>
+      <p:sp>
+        <p:nvSpPr>
+          <p:cNvPr id="78" name="GitHub repository QR label"/>
+          <p:cNvSpPr txBox="1"/>
+          <p:nvPr/>
+        </p:nvSpPr>
+        <p:spPr>
+          <a:xfrm>
+            <a:off x="28008072" y="20537424"/>
+            <a:ext cx="1261872" cy="274320"/>
+          </a:xfrm>
+          <a:prstGeom prst="rect">
+            <a:avLst/>
+          </a:prstGeom>
+          <a:noFill/>
+        </p:spPr>
+        <p:txBody>
+          <a:bodyPr wrap="none" lIns="0" rIns="0" tIns="0" bIns="0">
+            <a:spAutoFit/>
+          </a:bodyPr>
+          <a:lstStyle/>
+          <a:p>
+            <a:pPr algn="ctr"/>
+            <a:r>
+              <a:rPr sz="1200" b="1">
+                <a:solidFill>
+                  <a:srgbClr val="FFFFFF"/>
+                </a:solidFill>
+                <a:latin typeface="Arial"/>
+              </a:rPr>
+              <a:t>GITHUB REPO</a:t>
+            </a:r>
+          </a:p>
+        </p:txBody>
+      </p:sp>
     </p:spTree>
   </p:cSld>
   <p:clrMapOvr>

</xml_diff>

<commit_message>
Add YouTube demo QR code to poster
</commit_message>
<xml_diff>
--- a/docs/poster/MedLocate-poster.pptx
+++ b/docs/poster/MedLocate-poster.pptx
@@ -8180,7 +8180,7 @@
             <p:nvPr/>
           </p:nvPicPr>
           <p:blipFill>
-            <a:blip r:embed="rId13"/>
+            <a:blip r:embed="rId15"/>
             <a:stretch>
               <a:fillRect/>
             </a:stretch>
@@ -8204,7 +8204,7 @@
             <p:nvPr/>
           </p:nvPicPr>
           <p:blipFill>
-            <a:blip r:embed="rId8"/>
+            <a:blip r:embed="rId16"/>
             <a:stretch>
               <a:fillRect/>
             </a:stretch>
@@ -8220,41 +8220,6 @@
           </p:spPr>
         </p:pic>
       </p:grpSp>
-      <p:sp>
-        <p:nvSpPr>
-          <p:cNvPr id="78" name="GitHub repository QR label"/>
-          <p:cNvSpPr txBox="1"/>
-          <p:nvPr/>
-        </p:nvSpPr>
-        <p:spPr>
-          <a:xfrm>
-            <a:off x="28008072" y="20537424"/>
-            <a:ext cx="1261872" cy="274320"/>
-          </a:xfrm>
-          <a:prstGeom prst="rect">
-            <a:avLst/>
-          </a:prstGeom>
-          <a:noFill/>
-        </p:spPr>
-        <p:txBody>
-          <a:bodyPr wrap="none" lIns="0" rIns="0" tIns="0" bIns="0">
-            <a:spAutoFit/>
-          </a:bodyPr>
-          <a:lstStyle/>
-          <a:p>
-            <a:pPr algn="ctr"/>
-            <a:r>
-              <a:rPr sz="1200" b="1">
-                <a:solidFill>
-                  <a:srgbClr val="FFFFFF"/>
-                </a:solidFill>
-                <a:latin typeface="Arial"/>
-              </a:rPr>
-              <a:t>GITHUB REPO</a:t>
-            </a:r>
-          </a:p>
-        </p:txBody>
-      </p:sp>
     </p:spTree>
   </p:cSld>
   <p:clrMapOvr>

</xml_diff>